<commit_message>
feat: embed hi-res UI screenshots into presentation slides 5-14
Replaced placeholder rectangles with 2x-scale PNG exports from
pencil-welcome-desktop.pen for all 10 screen mockups (6 desktop, 4 mobile).

Co-Authored-By: Claude Opus 4.6 (1M context) <noreply@anthropic.com>
</commit_message>
<xml_diff>
--- a/docs/Mallard-Connect-UX-Presentation.pptx
+++ b/docs/Mallard-Connect-UX-Presentation.pptx
@@ -3800,53 +3800,6 @@
       </p:sp>
       <p:sp>
         <p:nvSpPr>
-          <p:cNvPr id="11" name="Rounded Rectangle 10"/>
-          <p:cNvSpPr/>
-          <p:nvPr/>
-        </p:nvSpPr>
-        <p:spPr>
-          <a:xfrm>
-            <a:off x="6400800" y="1371600"/>
-            <a:ext cx="5303520" cy="3291840"/>
-          </a:xfrm>
-          <a:prstGeom prst="roundRect">
-            <a:avLst>
-              <a:gd name="adj" fmla="val 2000"/>
-            </a:avLst>
-          </a:prstGeom>
-          <a:solidFill>
-            <a:srgbClr val="F3F4F6"/>
-          </a:solidFill>
-          <a:ln w="25400">
-            <a:solidFill>
-              <a:srgbClr val="D1D5DB"/>
-            </a:solidFill>
-          </a:ln>
-        </p:spPr>
-        <p:style>
-          <a:lnRef idx="1">
-            <a:schemeClr val="accent1"/>
-          </a:lnRef>
-          <a:fillRef idx="3">
-            <a:schemeClr val="accent1"/>
-          </a:fillRef>
-          <a:effectRef idx="2">
-            <a:schemeClr val="accent1"/>
-          </a:effectRef>
-          <a:fontRef idx="minor">
-            <a:schemeClr val="lt1"/>
-          </a:fontRef>
-        </p:style>
-        <p:txBody>
-          <a:bodyPr rtlCol="0" anchor="ctr"/>
-          <a:lstStyle/>
-          <a:p>
-            <a:pPr algn="ctr"/>
-          </a:p>
-        </p:txBody>
-      </p:sp>
-      <p:sp>
-        <p:nvSpPr>
           <p:cNvPr id="12" name="Rectangle 11"/>
           <p:cNvSpPr/>
           <p:nvPr/>
@@ -3960,6 +3913,32 @@
           </a:p>
         </p:txBody>
       </p:sp>
+      <p:pic>
+        <p:nvPicPr>
+          <p:cNvPr id="15" name="Picture 14" descr="New Lead Form - Desktop.png"/>
+          <p:cNvPicPr>
+            <a:picLocks noChangeAspect="1"/>
+          </p:cNvPicPr>
+          <p:nvPr/>
+        </p:nvPicPr>
+        <p:blipFill>
+          <a:blip r:embed="rId2"/>
+          <a:stretch>
+            <a:fillRect/>
+          </a:stretch>
+        </p:blipFill>
+        <p:spPr>
+          <a:xfrm>
+            <a:off x="6400800" y="1371600"/>
+            <a:ext cx="5303520" cy="3291840"/>
+          </a:xfrm>
+          <a:prstGeom prst="roundRect">
+            <a:avLst>
+              <a:gd name="adj" fmla="val 3000"/>
+            </a:avLst>
+          </a:prstGeom>
+        </p:spPr>
+      </p:pic>
     </p:spTree>
   </p:cSld>
   <p:clrMapOvr>
@@ -4420,53 +4399,6 @@
       </p:sp>
       <p:sp>
         <p:nvSpPr>
-          <p:cNvPr id="11" name="Rounded Rectangle 10"/>
-          <p:cNvSpPr/>
-          <p:nvPr/>
-        </p:nvSpPr>
-        <p:spPr>
-          <a:xfrm>
-            <a:off x="8686800" y="1097280"/>
-            <a:ext cx="2286000" cy="4937760"/>
-          </a:xfrm>
-          <a:prstGeom prst="roundRect">
-            <a:avLst>
-              <a:gd name="adj" fmla="val 8000"/>
-            </a:avLst>
-          </a:prstGeom>
-          <a:solidFill>
-            <a:srgbClr val="F3F4F6"/>
-          </a:solidFill>
-          <a:ln w="25400">
-            <a:solidFill>
-              <a:srgbClr val="D1D5DB"/>
-            </a:solidFill>
-          </a:ln>
-        </p:spPr>
-        <p:style>
-          <a:lnRef idx="1">
-            <a:schemeClr val="accent1"/>
-          </a:lnRef>
-          <a:fillRef idx="3">
-            <a:schemeClr val="accent1"/>
-          </a:fillRef>
-          <a:effectRef idx="2">
-            <a:schemeClr val="accent1"/>
-          </a:effectRef>
-          <a:fontRef idx="minor">
-            <a:schemeClr val="lt1"/>
-          </a:fontRef>
-        </p:style>
-        <p:txBody>
-          <a:bodyPr rtlCol="0" anchor="ctr"/>
-          <a:lstStyle/>
-          <a:p>
-            <a:pPr algn="ctr"/>
-          </a:p>
-        </p:txBody>
-      </p:sp>
-      <p:sp>
-        <p:nvSpPr>
           <p:cNvPr id="12" name="Rectangle 11"/>
           <p:cNvSpPr/>
           <p:nvPr/>
@@ -4616,6 +4548,32 @@
           </a:p>
         </p:txBody>
       </p:sp>
+      <p:pic>
+        <p:nvPicPr>
+          <p:cNvPr id="16" name="Picture 15" descr="Quick Capture - Mobile.png"/>
+          <p:cNvPicPr>
+            <a:picLocks noChangeAspect="1"/>
+          </p:cNvPicPr>
+          <p:nvPr/>
+        </p:nvPicPr>
+        <p:blipFill>
+          <a:blip r:embed="rId2"/>
+          <a:stretch>
+            <a:fillRect/>
+          </a:stretch>
+        </p:blipFill>
+        <p:spPr>
+          <a:xfrm>
+            <a:off x="8686800" y="1097280"/>
+            <a:ext cx="2286000" cy="4937760"/>
+          </a:xfrm>
+          <a:prstGeom prst="roundRect">
+            <a:avLst>
+              <a:gd name="adj" fmla="val 3000"/>
+            </a:avLst>
+          </a:prstGeom>
+        </p:spPr>
+      </p:pic>
     </p:spTree>
   </p:cSld>
   <p:clrMapOvr>
@@ -5076,53 +5034,6 @@
       </p:sp>
       <p:sp>
         <p:nvSpPr>
-          <p:cNvPr id="11" name="Rounded Rectangle 10"/>
-          <p:cNvSpPr/>
-          <p:nvPr/>
-        </p:nvSpPr>
-        <p:spPr>
-          <a:xfrm>
-            <a:off x="6400800" y="1371600"/>
-            <a:ext cx="5303520" cy="3291840"/>
-          </a:xfrm>
-          <a:prstGeom prst="roundRect">
-            <a:avLst>
-              <a:gd name="adj" fmla="val 2000"/>
-            </a:avLst>
-          </a:prstGeom>
-          <a:solidFill>
-            <a:srgbClr val="F3F4F6"/>
-          </a:solidFill>
-          <a:ln w="25400">
-            <a:solidFill>
-              <a:srgbClr val="D1D5DB"/>
-            </a:solidFill>
-          </a:ln>
-        </p:spPr>
-        <p:style>
-          <a:lnRef idx="1">
-            <a:schemeClr val="accent1"/>
-          </a:lnRef>
-          <a:fillRef idx="3">
-            <a:schemeClr val="accent1"/>
-          </a:fillRef>
-          <a:effectRef idx="2">
-            <a:schemeClr val="accent1"/>
-          </a:effectRef>
-          <a:fontRef idx="minor">
-            <a:schemeClr val="lt1"/>
-          </a:fontRef>
-        </p:style>
-        <p:txBody>
-          <a:bodyPr rtlCol="0" anchor="ctr"/>
-          <a:lstStyle/>
-          <a:p>
-            <a:pPr algn="ctr"/>
-          </a:p>
-        </p:txBody>
-      </p:sp>
-      <p:sp>
-        <p:nvSpPr>
           <p:cNvPr id="12" name="Rectangle 11"/>
           <p:cNvSpPr/>
           <p:nvPr/>
@@ -5236,6 +5147,32 @@
           </a:p>
         </p:txBody>
       </p:sp>
+      <p:pic>
+        <p:nvPicPr>
+          <p:cNvPr id="15" name="Picture 14" descr="Prospect Detail - Desktop.png"/>
+          <p:cNvPicPr>
+            <a:picLocks noChangeAspect="1"/>
+          </p:cNvPicPr>
+          <p:nvPr/>
+        </p:nvPicPr>
+        <p:blipFill>
+          <a:blip r:embed="rId2"/>
+          <a:stretch>
+            <a:fillRect/>
+          </a:stretch>
+        </p:blipFill>
+        <p:spPr>
+          <a:xfrm>
+            <a:off x="6400800" y="1371600"/>
+            <a:ext cx="5303520" cy="3291840"/>
+          </a:xfrm>
+          <a:prstGeom prst="roundRect">
+            <a:avLst>
+              <a:gd name="adj" fmla="val 3000"/>
+            </a:avLst>
+          </a:prstGeom>
+        </p:spPr>
+      </p:pic>
     </p:spTree>
   </p:cSld>
   <p:clrMapOvr>
@@ -5696,53 +5633,6 @@
       </p:sp>
       <p:sp>
         <p:nvSpPr>
-          <p:cNvPr id="11" name="Rounded Rectangle 10"/>
-          <p:cNvSpPr/>
-          <p:nvPr/>
-        </p:nvSpPr>
-        <p:spPr>
-          <a:xfrm>
-            <a:off x="8686800" y="1097280"/>
-            <a:ext cx="2286000" cy="4937760"/>
-          </a:xfrm>
-          <a:prstGeom prst="roundRect">
-            <a:avLst>
-              <a:gd name="adj" fmla="val 8000"/>
-            </a:avLst>
-          </a:prstGeom>
-          <a:solidFill>
-            <a:srgbClr val="F3F4F6"/>
-          </a:solidFill>
-          <a:ln w="25400">
-            <a:solidFill>
-              <a:srgbClr val="D1D5DB"/>
-            </a:solidFill>
-          </a:ln>
-        </p:spPr>
-        <p:style>
-          <a:lnRef idx="1">
-            <a:schemeClr val="accent1"/>
-          </a:lnRef>
-          <a:fillRef idx="3">
-            <a:schemeClr val="accent1"/>
-          </a:fillRef>
-          <a:effectRef idx="2">
-            <a:schemeClr val="accent1"/>
-          </a:effectRef>
-          <a:fontRef idx="minor">
-            <a:schemeClr val="lt1"/>
-          </a:fontRef>
-        </p:style>
-        <p:txBody>
-          <a:bodyPr rtlCol="0" anchor="ctr"/>
-          <a:lstStyle/>
-          <a:p>
-            <a:pPr algn="ctr"/>
-          </a:p>
-        </p:txBody>
-      </p:sp>
-      <p:sp>
-        <p:nvSpPr>
           <p:cNvPr id="12" name="Rectangle 11"/>
           <p:cNvSpPr/>
           <p:nvPr/>
@@ -5892,6 +5782,32 @@
           </a:p>
         </p:txBody>
       </p:sp>
+      <p:pic>
+        <p:nvPicPr>
+          <p:cNvPr id="16" name="Picture 15" descr="Pipeline List - Mobile.png"/>
+          <p:cNvPicPr>
+            <a:picLocks noChangeAspect="1"/>
+          </p:cNvPicPr>
+          <p:nvPr/>
+        </p:nvPicPr>
+        <p:blipFill>
+          <a:blip r:embed="rId2"/>
+          <a:stretch>
+            <a:fillRect/>
+          </a:stretch>
+        </p:blipFill>
+        <p:spPr>
+          <a:xfrm>
+            <a:off x="8686800" y="1097280"/>
+            <a:ext cx="2286000" cy="4937760"/>
+          </a:xfrm>
+          <a:prstGeom prst="roundRect">
+            <a:avLst>
+              <a:gd name="adj" fmla="val 3000"/>
+            </a:avLst>
+          </a:prstGeom>
+        </p:spPr>
+      </p:pic>
     </p:spTree>
   </p:cSld>
   <p:clrMapOvr>
@@ -6384,53 +6300,6 @@
       </p:sp>
       <p:sp>
         <p:nvSpPr>
-          <p:cNvPr id="11" name="Rounded Rectangle 10"/>
-          <p:cNvSpPr/>
-          <p:nvPr/>
-        </p:nvSpPr>
-        <p:spPr>
-          <a:xfrm>
-            <a:off x="6400800" y="1371600"/>
-            <a:ext cx="5303520" cy="3291840"/>
-          </a:xfrm>
-          <a:prstGeom prst="roundRect">
-            <a:avLst>
-              <a:gd name="adj" fmla="val 2000"/>
-            </a:avLst>
-          </a:prstGeom>
-          <a:solidFill>
-            <a:srgbClr val="F3F4F6"/>
-          </a:solidFill>
-          <a:ln w="25400">
-            <a:solidFill>
-              <a:srgbClr val="D1D5DB"/>
-            </a:solidFill>
-          </a:ln>
-        </p:spPr>
-        <p:style>
-          <a:lnRef idx="1">
-            <a:schemeClr val="accent1"/>
-          </a:lnRef>
-          <a:fillRef idx="3">
-            <a:schemeClr val="accent1"/>
-          </a:fillRef>
-          <a:effectRef idx="2">
-            <a:schemeClr val="accent1"/>
-          </a:effectRef>
-          <a:fontRef idx="minor">
-            <a:schemeClr val="lt1"/>
-          </a:fontRef>
-        </p:style>
-        <p:txBody>
-          <a:bodyPr rtlCol="0" anchor="ctr"/>
-          <a:lstStyle/>
-          <a:p>
-            <a:pPr algn="ctr"/>
-          </a:p>
-        </p:txBody>
-      </p:sp>
-      <p:sp>
-        <p:nvSpPr>
           <p:cNvPr id="12" name="Rectangle 11"/>
           <p:cNvSpPr/>
           <p:nvPr/>
@@ -6544,6 +6413,32 @@
           </a:p>
         </p:txBody>
       </p:sp>
+      <p:pic>
+        <p:nvPicPr>
+          <p:cNvPr id="15" name="Picture 14" descr="MAB Import - Desktop.png"/>
+          <p:cNvPicPr>
+            <a:picLocks noChangeAspect="1"/>
+          </p:cNvPicPr>
+          <p:nvPr/>
+        </p:nvPicPr>
+        <p:blipFill>
+          <a:blip r:embed="rId2"/>
+          <a:stretch>
+            <a:fillRect/>
+          </a:stretch>
+        </p:blipFill>
+        <p:spPr>
+          <a:xfrm>
+            <a:off x="6400800" y="1371600"/>
+            <a:ext cx="5303520" cy="3291840"/>
+          </a:xfrm>
+          <a:prstGeom prst="roundRect">
+            <a:avLst>
+              <a:gd name="adj" fmla="val 3000"/>
+            </a:avLst>
+          </a:prstGeom>
+        </p:spPr>
+      </p:pic>
     </p:spTree>
   </p:cSld>
   <p:clrMapOvr>
@@ -13902,53 +13797,6 @@
       </p:sp>
       <p:sp>
         <p:nvSpPr>
-          <p:cNvPr id="11" name="Rounded Rectangle 10"/>
-          <p:cNvSpPr/>
-          <p:nvPr/>
-        </p:nvSpPr>
-        <p:spPr>
-          <a:xfrm>
-            <a:off x="6400800" y="1371600"/>
-            <a:ext cx="5303520" cy="3291840"/>
-          </a:xfrm>
-          <a:prstGeom prst="roundRect">
-            <a:avLst>
-              <a:gd name="adj" fmla="val 2000"/>
-            </a:avLst>
-          </a:prstGeom>
-          <a:solidFill>
-            <a:srgbClr val="F3F4F6"/>
-          </a:solidFill>
-          <a:ln w="25400">
-            <a:solidFill>
-              <a:srgbClr val="D1D5DB"/>
-            </a:solidFill>
-          </a:ln>
-        </p:spPr>
-        <p:style>
-          <a:lnRef idx="1">
-            <a:schemeClr val="accent1"/>
-          </a:lnRef>
-          <a:fillRef idx="3">
-            <a:schemeClr val="accent1"/>
-          </a:fillRef>
-          <a:effectRef idx="2">
-            <a:schemeClr val="accent1"/>
-          </a:effectRef>
-          <a:fontRef idx="minor">
-            <a:schemeClr val="lt1"/>
-          </a:fontRef>
-        </p:style>
-        <p:txBody>
-          <a:bodyPr rtlCol="0" anchor="ctr"/>
-          <a:lstStyle/>
-          <a:p>
-            <a:pPr algn="ctr"/>
-          </a:p>
-        </p:txBody>
-      </p:sp>
-      <p:sp>
-        <p:nvSpPr>
           <p:cNvPr id="12" name="Rectangle 11"/>
           <p:cNvSpPr/>
           <p:nvPr/>
@@ -14062,6 +13910,32 @@
           </a:p>
         </p:txBody>
       </p:sp>
+      <p:pic>
+        <p:nvPicPr>
+          <p:cNvPr id="15" name="Picture 14" descr="Manager Dashboard - Desktop.png"/>
+          <p:cNvPicPr>
+            <a:picLocks noChangeAspect="1"/>
+          </p:cNvPicPr>
+          <p:nvPr/>
+        </p:nvPicPr>
+        <p:blipFill>
+          <a:blip r:embed="rId2"/>
+          <a:stretch>
+            <a:fillRect/>
+          </a:stretch>
+        </p:blipFill>
+        <p:spPr>
+          <a:xfrm>
+            <a:off x="6400800" y="1371600"/>
+            <a:ext cx="5303520" cy="3291840"/>
+          </a:xfrm>
+          <a:prstGeom prst="roundRect">
+            <a:avLst>
+              <a:gd name="adj" fmla="val 3000"/>
+            </a:avLst>
+          </a:prstGeom>
+        </p:spPr>
+      </p:pic>
     </p:spTree>
   </p:cSld>
   <p:clrMapOvr>
@@ -14506,53 +14380,6 @@
       </p:sp>
       <p:sp>
         <p:nvSpPr>
-          <p:cNvPr id="11" name="Rounded Rectangle 10"/>
-          <p:cNvSpPr/>
-          <p:nvPr/>
-        </p:nvSpPr>
-        <p:spPr>
-          <a:xfrm>
-            <a:off x="8686800" y="1097280"/>
-            <a:ext cx="2286000" cy="4937760"/>
-          </a:xfrm>
-          <a:prstGeom prst="roundRect">
-            <a:avLst>
-              <a:gd name="adj" fmla="val 8000"/>
-            </a:avLst>
-          </a:prstGeom>
-          <a:solidFill>
-            <a:srgbClr val="F3F4F6"/>
-          </a:solidFill>
-          <a:ln w="25400">
-            <a:solidFill>
-              <a:srgbClr val="D1D5DB"/>
-            </a:solidFill>
-          </a:ln>
-        </p:spPr>
-        <p:style>
-          <a:lnRef idx="1">
-            <a:schemeClr val="accent1"/>
-          </a:lnRef>
-          <a:fillRef idx="3">
-            <a:schemeClr val="accent1"/>
-          </a:fillRef>
-          <a:effectRef idx="2">
-            <a:schemeClr val="accent1"/>
-          </a:effectRef>
-          <a:fontRef idx="minor">
-            <a:schemeClr val="lt1"/>
-          </a:fontRef>
-        </p:style>
-        <p:txBody>
-          <a:bodyPr rtlCol="0" anchor="ctr"/>
-          <a:lstStyle/>
-          <a:p>
-            <a:pPr algn="ctr"/>
-          </a:p>
-        </p:txBody>
-      </p:sp>
-      <p:sp>
-        <p:nvSpPr>
           <p:cNvPr id="12" name="Rectangle 11"/>
           <p:cNvSpPr/>
           <p:nvPr/>
@@ -14702,6 +14529,32 @@
           </a:p>
         </p:txBody>
       </p:sp>
+      <p:pic>
+        <p:nvPicPr>
+          <p:cNvPr id="16" name="Picture 15" descr="Manager Dashboard - Mobile.png"/>
+          <p:cNvPicPr>
+            <a:picLocks noChangeAspect="1"/>
+          </p:cNvPicPr>
+          <p:nvPr/>
+        </p:nvPicPr>
+        <p:blipFill>
+          <a:blip r:embed="rId2"/>
+          <a:stretch>
+            <a:fillRect/>
+          </a:stretch>
+        </p:blipFill>
+        <p:spPr>
+          <a:xfrm>
+            <a:off x="8686800" y="1097280"/>
+            <a:ext cx="2286000" cy="4937760"/>
+          </a:xfrm>
+          <a:prstGeom prst="roundRect">
+            <a:avLst>
+              <a:gd name="adj" fmla="val 3000"/>
+            </a:avLst>
+          </a:prstGeom>
+        </p:spPr>
+      </p:pic>
     </p:spTree>
   </p:cSld>
   <p:clrMapOvr>
@@ -15162,53 +15015,6 @@
       </p:sp>
       <p:sp>
         <p:nvSpPr>
-          <p:cNvPr id="11" name="Rounded Rectangle 10"/>
-          <p:cNvSpPr/>
-          <p:nvPr/>
-        </p:nvSpPr>
-        <p:spPr>
-          <a:xfrm>
-            <a:off x="6400800" y="1371600"/>
-            <a:ext cx="5303520" cy="3291840"/>
-          </a:xfrm>
-          <a:prstGeom prst="roundRect">
-            <a:avLst>
-              <a:gd name="adj" fmla="val 2000"/>
-            </a:avLst>
-          </a:prstGeom>
-          <a:solidFill>
-            <a:srgbClr val="F3F4F6"/>
-          </a:solidFill>
-          <a:ln w="25400">
-            <a:solidFill>
-              <a:srgbClr val="D1D5DB"/>
-            </a:solidFill>
-          </a:ln>
-        </p:spPr>
-        <p:style>
-          <a:lnRef idx="1">
-            <a:schemeClr val="accent1"/>
-          </a:lnRef>
-          <a:fillRef idx="3">
-            <a:schemeClr val="accent1"/>
-          </a:fillRef>
-          <a:effectRef idx="2">
-            <a:schemeClr val="accent1"/>
-          </a:effectRef>
-          <a:fontRef idx="minor">
-            <a:schemeClr val="lt1"/>
-          </a:fontRef>
-        </p:style>
-        <p:txBody>
-          <a:bodyPr rtlCol="0" anchor="ctr"/>
-          <a:lstStyle/>
-          <a:p>
-            <a:pPr algn="ctr"/>
-          </a:p>
-        </p:txBody>
-      </p:sp>
-      <p:sp>
-        <p:nvSpPr>
           <p:cNvPr id="12" name="Rectangle 11"/>
           <p:cNvSpPr/>
           <p:nvPr/>
@@ -15322,6 +15128,32 @@
           </a:p>
         </p:txBody>
       </p:sp>
+      <p:pic>
+        <p:nvPicPr>
+          <p:cNvPr id="15" name="Picture 14" descr="Pipeline Board - Desktop.png"/>
+          <p:cNvPicPr>
+            <a:picLocks noChangeAspect="1"/>
+          </p:cNvPicPr>
+          <p:nvPr/>
+        </p:nvPicPr>
+        <p:blipFill>
+          <a:blip r:embed="rId2"/>
+          <a:stretch>
+            <a:fillRect/>
+          </a:stretch>
+        </p:blipFill>
+        <p:spPr>
+          <a:xfrm>
+            <a:off x="6400800" y="1371600"/>
+            <a:ext cx="5303520" cy="3291840"/>
+          </a:xfrm>
+          <a:prstGeom prst="roundRect">
+            <a:avLst>
+              <a:gd name="adj" fmla="val 3000"/>
+            </a:avLst>
+          </a:prstGeom>
+        </p:spPr>
+      </p:pic>
     </p:spTree>
   </p:cSld>
   <p:clrMapOvr>
@@ -15782,53 +15614,6 @@
       </p:sp>
       <p:sp>
         <p:nvSpPr>
-          <p:cNvPr id="11" name="Rounded Rectangle 10"/>
-          <p:cNvSpPr/>
-          <p:nvPr/>
-        </p:nvSpPr>
-        <p:spPr>
-          <a:xfrm>
-            <a:off x="6400800" y="1371600"/>
-            <a:ext cx="5303520" cy="3291840"/>
-          </a:xfrm>
-          <a:prstGeom prst="roundRect">
-            <a:avLst>
-              <a:gd name="adj" fmla="val 2000"/>
-            </a:avLst>
-          </a:prstGeom>
-          <a:solidFill>
-            <a:srgbClr val="F3F4F6"/>
-          </a:solidFill>
-          <a:ln w="25400">
-            <a:solidFill>
-              <a:srgbClr val="D1D5DB"/>
-            </a:solidFill>
-          </a:ln>
-        </p:spPr>
-        <p:style>
-          <a:lnRef idx="1">
-            <a:schemeClr val="accent1"/>
-          </a:lnRef>
-          <a:fillRef idx="3">
-            <a:schemeClr val="accent1"/>
-          </a:fillRef>
-          <a:effectRef idx="2">
-            <a:schemeClr val="accent1"/>
-          </a:effectRef>
-          <a:fontRef idx="minor">
-            <a:schemeClr val="lt1"/>
-          </a:fontRef>
-        </p:style>
-        <p:txBody>
-          <a:bodyPr rtlCol="0" anchor="ctr"/>
-          <a:lstStyle/>
-          <a:p>
-            <a:pPr algn="ctr"/>
-          </a:p>
-        </p:txBody>
-      </p:sp>
-      <p:sp>
-        <p:nvSpPr>
           <p:cNvPr id="12" name="Rectangle 11"/>
           <p:cNvSpPr/>
           <p:nvPr/>
@@ -15942,6 +15727,32 @@
           </a:p>
         </p:txBody>
       </p:sp>
+      <p:pic>
+        <p:nvPicPr>
+          <p:cNvPr id="15" name="Picture 14" descr="My Day Dashboard - Desktop.png"/>
+          <p:cNvPicPr>
+            <a:picLocks noChangeAspect="1"/>
+          </p:cNvPicPr>
+          <p:nvPr/>
+        </p:nvPicPr>
+        <p:blipFill>
+          <a:blip r:embed="rId2"/>
+          <a:stretch>
+            <a:fillRect/>
+          </a:stretch>
+        </p:blipFill>
+        <p:spPr>
+          <a:xfrm>
+            <a:off x="6400800" y="1371600"/>
+            <a:ext cx="5303520" cy="3291840"/>
+          </a:xfrm>
+          <a:prstGeom prst="roundRect">
+            <a:avLst>
+              <a:gd name="adj" fmla="val 3000"/>
+            </a:avLst>
+          </a:prstGeom>
+        </p:spPr>
+      </p:pic>
     </p:spTree>
   </p:cSld>
   <p:clrMapOvr>
@@ -16402,53 +16213,6 @@
       </p:sp>
       <p:sp>
         <p:nvSpPr>
-          <p:cNvPr id="11" name="Rounded Rectangle 10"/>
-          <p:cNvSpPr/>
-          <p:nvPr/>
-        </p:nvSpPr>
-        <p:spPr>
-          <a:xfrm>
-            <a:off x="8686800" y="1097280"/>
-            <a:ext cx="2286000" cy="4937760"/>
-          </a:xfrm>
-          <a:prstGeom prst="roundRect">
-            <a:avLst>
-              <a:gd name="adj" fmla="val 8000"/>
-            </a:avLst>
-          </a:prstGeom>
-          <a:solidFill>
-            <a:srgbClr val="F3F4F6"/>
-          </a:solidFill>
-          <a:ln w="25400">
-            <a:solidFill>
-              <a:srgbClr val="D1D5DB"/>
-            </a:solidFill>
-          </a:ln>
-        </p:spPr>
-        <p:style>
-          <a:lnRef idx="1">
-            <a:schemeClr val="accent1"/>
-          </a:lnRef>
-          <a:fillRef idx="3">
-            <a:schemeClr val="accent1"/>
-          </a:fillRef>
-          <a:effectRef idx="2">
-            <a:schemeClr val="accent1"/>
-          </a:effectRef>
-          <a:fontRef idx="minor">
-            <a:schemeClr val="lt1"/>
-          </a:fontRef>
-        </p:style>
-        <p:txBody>
-          <a:bodyPr rtlCol="0" anchor="ctr"/>
-          <a:lstStyle/>
-          <a:p>
-            <a:pPr algn="ctr"/>
-          </a:p>
-        </p:txBody>
-      </p:sp>
-      <p:sp>
-        <p:nvSpPr>
           <p:cNvPr id="12" name="Rectangle 11"/>
           <p:cNvSpPr/>
           <p:nvPr/>
@@ -16598,6 +16362,32 @@
           </a:p>
         </p:txBody>
       </p:sp>
+      <p:pic>
+        <p:nvPicPr>
+          <p:cNvPr id="16" name="Picture 15" descr="My Day - Mobile.png"/>
+          <p:cNvPicPr>
+            <a:picLocks noChangeAspect="1"/>
+          </p:cNvPicPr>
+          <p:nvPr/>
+        </p:nvPicPr>
+        <p:blipFill>
+          <a:blip r:embed="rId2"/>
+          <a:stretch>
+            <a:fillRect/>
+          </a:stretch>
+        </p:blipFill>
+        <p:spPr>
+          <a:xfrm>
+            <a:off x="8686800" y="1097280"/>
+            <a:ext cx="2286000" cy="4937760"/>
+          </a:xfrm>
+          <a:prstGeom prst="roundRect">
+            <a:avLst>
+              <a:gd name="adj" fmla="val 3000"/>
+            </a:avLst>
+          </a:prstGeom>
+        </p:spPr>
+      </p:pic>
     </p:spTree>
   </p:cSld>
   <p:clrMapOvr>

</xml_diff>